<commit_message>
Replace final presentation PPTX
Update reports/Final/final_presentation_murisetty_sharmila.pptx with a revised binary version containing the finalized presentation slides.
</commit_message>
<xml_diff>
--- a/reports/Final/final_presentation_murisetty_sharmila.pptx
+++ b/reports/Final/final_presentation_murisetty_sharmila.pptx
@@ -213,7 +213,7 @@
           <a:p>
             <a:fld id="{FD8E1188-F655-4BFF-87C9-101FED72F5A0}" type="datetimeFigureOut">
               <a:rPr lang="en-CA" smtClean="0"/>
-              <a:t>2026-04-12</a:t>
+              <a:t>2026-04-14</a:t>
             </a:fld>
             <a:endParaRPr lang="en-CA"/>
           </a:p>
@@ -1386,7 +1386,7 @@
           <a:p>
             <a:fld id="{2A7AB0EC-7076-4D52-8CB0-1B41AFB3693F}" type="datetimeFigureOut">
               <a:rPr lang="en-CA" smtClean="0"/>
-              <a:t>2026-04-12</a:t>
+              <a:t>2026-04-14</a:t>
             </a:fld>
             <a:endParaRPr lang="en-CA"/>
           </a:p>
@@ -1586,7 +1586,7 @@
           <a:p>
             <a:fld id="{2A7AB0EC-7076-4D52-8CB0-1B41AFB3693F}" type="datetimeFigureOut">
               <a:rPr lang="en-CA" smtClean="0"/>
-              <a:t>2026-04-12</a:t>
+              <a:t>2026-04-14</a:t>
             </a:fld>
             <a:endParaRPr lang="en-CA"/>
           </a:p>
@@ -1796,7 +1796,7 @@
           <a:p>
             <a:fld id="{2A7AB0EC-7076-4D52-8CB0-1B41AFB3693F}" type="datetimeFigureOut">
               <a:rPr lang="en-CA" smtClean="0"/>
-              <a:t>2026-04-12</a:t>
+              <a:t>2026-04-14</a:t>
             </a:fld>
             <a:endParaRPr lang="en-CA"/>
           </a:p>
@@ -2570,7 +2570,7 @@
           <a:p>
             <a:fld id="{2A7AB0EC-7076-4D52-8CB0-1B41AFB3693F}" type="datetimeFigureOut">
               <a:rPr lang="en-CA" smtClean="0"/>
-              <a:t>2026-04-12</a:t>
+              <a:t>2026-04-14</a:t>
             </a:fld>
             <a:endParaRPr lang="en-CA"/>
           </a:p>
@@ -2916,7 +2916,7 @@
           <a:p>
             <a:fld id="{2A7AB0EC-7076-4D52-8CB0-1B41AFB3693F}" type="datetimeFigureOut">
               <a:rPr lang="en-CA" smtClean="0"/>
-              <a:t>2026-04-12</a:t>
+              <a:t>2026-04-14</a:t>
             </a:fld>
             <a:endParaRPr lang="en-CA"/>
           </a:p>
@@ -3184,7 +3184,7 @@
           <a:p>
             <a:fld id="{2A7AB0EC-7076-4D52-8CB0-1B41AFB3693F}" type="datetimeFigureOut">
               <a:rPr lang="en-CA" smtClean="0"/>
-              <a:t>2026-04-12</a:t>
+              <a:t>2026-04-14</a:t>
             </a:fld>
             <a:endParaRPr lang="en-CA"/>
           </a:p>
@@ -3599,7 +3599,7 @@
           <a:p>
             <a:fld id="{2A7AB0EC-7076-4D52-8CB0-1B41AFB3693F}" type="datetimeFigureOut">
               <a:rPr lang="en-CA" smtClean="0"/>
-              <a:t>2026-04-12</a:t>
+              <a:t>2026-04-14</a:t>
             </a:fld>
             <a:endParaRPr lang="en-CA"/>
           </a:p>
@@ -3741,7 +3741,7 @@
           <a:p>
             <a:fld id="{2A7AB0EC-7076-4D52-8CB0-1B41AFB3693F}" type="datetimeFigureOut">
               <a:rPr lang="en-CA" smtClean="0"/>
-              <a:t>2026-04-12</a:t>
+              <a:t>2026-04-14</a:t>
             </a:fld>
             <a:endParaRPr lang="en-CA"/>
           </a:p>
@@ -3854,7 +3854,7 @@
           <a:p>
             <a:fld id="{2A7AB0EC-7076-4D52-8CB0-1B41AFB3693F}" type="datetimeFigureOut">
               <a:rPr lang="en-CA" smtClean="0"/>
-              <a:t>2026-04-12</a:t>
+              <a:t>2026-04-14</a:t>
             </a:fld>
             <a:endParaRPr lang="en-CA"/>
           </a:p>
@@ -4167,7 +4167,7 @@
           <a:p>
             <a:fld id="{2A7AB0EC-7076-4D52-8CB0-1B41AFB3693F}" type="datetimeFigureOut">
               <a:rPr lang="en-CA" smtClean="0"/>
-              <a:t>2026-04-12</a:t>
+              <a:t>2026-04-14</a:t>
             </a:fld>
             <a:endParaRPr lang="en-CA"/>
           </a:p>
@@ -4456,7 +4456,7 @@
           <a:p>
             <a:fld id="{2A7AB0EC-7076-4D52-8CB0-1B41AFB3693F}" type="datetimeFigureOut">
               <a:rPr lang="en-CA" smtClean="0"/>
-              <a:t>2026-04-12</a:t>
+              <a:t>2026-04-14</a:t>
             </a:fld>
             <a:endParaRPr lang="en-CA"/>
           </a:p>
@@ -4699,7 +4699,7 @@
           <a:p>
             <a:fld id="{2A7AB0EC-7076-4D52-8CB0-1B41AFB3693F}" type="datetimeFigureOut">
               <a:rPr lang="en-CA" smtClean="0"/>
-              <a:t>2026-04-12</a:t>
+              <a:t>2026-04-14</a:t>
             </a:fld>
             <a:endParaRPr lang="en-CA"/>
           </a:p>
@@ -16214,15 +16214,13 @@
           </a:bodyPr>
           <a:lstStyle/>
           <a:p>
-            <a:pPr indent="-228600">
+            <a:pPr>
               <a:lnSpc>
                 <a:spcPct val="90000"/>
               </a:lnSpc>
               <a:spcAft>
                 <a:spcPts val="600"/>
               </a:spcAft>
-              <a:buFont typeface="Arial" panose="020B0604020202020204" pitchFamily="34" charset="0"/>
-              <a:buChar char="•"/>
             </a:pPr>
             <a:r>
               <a:rPr lang="en-US" sz="1400" dirty="0"/>
@@ -16246,15 +16244,13 @@
             </a:r>
           </a:p>
           <a:p>
-            <a:pPr indent="-228600">
+            <a:pPr>
               <a:lnSpc>
                 <a:spcPct val="90000"/>
               </a:lnSpc>
               <a:spcAft>
                 <a:spcPts val="600"/>
               </a:spcAft>
-              <a:buFont typeface="Arial" panose="020B0604020202020204" pitchFamily="34" charset="0"/>
-              <a:buChar char="•"/>
             </a:pPr>
             <a:r>
               <a:rPr lang="en-US" sz="1400" dirty="0"/>
@@ -16294,15 +16290,13 @@
             </a:r>
           </a:p>
           <a:p>
-            <a:pPr indent="-228600">
+            <a:pPr>
               <a:lnSpc>
                 <a:spcPct val="90000"/>
               </a:lnSpc>
               <a:spcAft>
                 <a:spcPts val="600"/>
               </a:spcAft>
-              <a:buFont typeface="Arial" panose="020B0604020202020204" pitchFamily="34" charset="0"/>
-              <a:buChar char="•"/>
             </a:pPr>
             <a:r>
               <a:rPr lang="en-US" sz="1400" dirty="0"/>
@@ -16342,15 +16336,13 @@
             </a:r>
           </a:p>
           <a:p>
-            <a:pPr indent="-228600">
+            <a:pPr>
               <a:lnSpc>
                 <a:spcPct val="90000"/>
               </a:lnSpc>
               <a:spcAft>
                 <a:spcPts val="600"/>
               </a:spcAft>
-              <a:buFont typeface="Arial" panose="020B0604020202020204" pitchFamily="34" charset="0"/>
-              <a:buChar char="•"/>
             </a:pPr>
             <a:r>
               <a:rPr lang="en-US" sz="1400" dirty="0"/>

</xml_diff>